<commit_message>
updated PPT and PDF files for 12th presentation
</commit_message>
<xml_diff>
--- a/12/12_eloadas_soap_grpc_websocket.pptx
+++ b/12/12_eloadas_soap_grpc_websocket.pptx
@@ -213,7 +213,7 @@
           <a:p>
             <a:fld id="{4C482E4E-5CEC-44A9-BF2B-512FB3B5604F}" type="datetimeFigureOut">
               <a:rPr lang="en-US" smtClean="0"/>
-              <a:t>2/8/2026</a:t>
+              <a:t>5/3/2026</a:t>
             </a:fld>
             <a:endParaRPr lang="en-US"/>
           </a:p>
@@ -7138,7 +7138,7 @@
           <a:p>
             <a:fld id="{E80C50CD-E178-4744-9B35-B2F624D6C5E9}" type="datetimeFigureOut">
               <a:rPr lang="en-US" smtClean="0"/>
-              <a:t>2/8/2026</a:t>
+              <a:t>5/3/2026</a:t>
             </a:fld>
             <a:endParaRPr lang="en-US"/>
           </a:p>
@@ -7336,7 +7336,7 @@
           <a:p>
             <a:fld id="{E80C50CD-E178-4744-9B35-B2F624D6C5E9}" type="datetimeFigureOut">
               <a:rPr lang="en-US" smtClean="0"/>
-              <a:t>2/8/2026</a:t>
+              <a:t>5/3/2026</a:t>
             </a:fld>
             <a:endParaRPr lang="en-US"/>
           </a:p>
@@ -7544,7 +7544,7 @@
           <a:p>
             <a:fld id="{E80C50CD-E178-4744-9B35-B2F624D6C5E9}" type="datetimeFigureOut">
               <a:rPr lang="en-US" smtClean="0"/>
-              <a:t>2/8/2026</a:t>
+              <a:t>5/3/2026</a:t>
             </a:fld>
             <a:endParaRPr lang="en-US"/>
           </a:p>
@@ -7794,7 +7794,7 @@
           <a:p>
             <a:fld id="{E80C50CD-E178-4744-9B35-B2F624D6C5E9}" type="datetimeFigureOut">
               <a:rPr lang="en-US" smtClean="0"/>
-              <a:t>2/8/2026</a:t>
+              <a:t>5/3/2026</a:t>
             </a:fld>
             <a:endParaRPr lang="en-US"/>
           </a:p>
@@ -8073,7 +8073,7 @@
           <a:p>
             <a:fld id="{E80C50CD-E178-4744-9B35-B2F624D6C5E9}" type="datetimeFigureOut">
               <a:rPr lang="en-US" smtClean="0"/>
-              <a:t>2/8/2026</a:t>
+              <a:t>5/3/2026</a:t>
             </a:fld>
             <a:endParaRPr lang="en-US"/>
           </a:p>
@@ -8390,7 +8390,7 @@
           <a:p>
             <a:fld id="{E80C50CD-E178-4744-9B35-B2F624D6C5E9}" type="datetimeFigureOut">
               <a:rPr lang="en-US" smtClean="0"/>
-              <a:t>2/8/2026</a:t>
+              <a:t>5/3/2026</a:t>
             </a:fld>
             <a:endParaRPr lang="en-US"/>
           </a:p>
@@ -8806,7 +8806,7 @@
           <a:p>
             <a:fld id="{E80C50CD-E178-4744-9B35-B2F624D6C5E9}" type="datetimeFigureOut">
               <a:rPr lang="en-US" smtClean="0"/>
-              <a:t>2/8/2026</a:t>
+              <a:t>5/3/2026</a:t>
             </a:fld>
             <a:endParaRPr lang="en-US"/>
           </a:p>
@@ -8947,7 +8947,7 @@
           <a:p>
             <a:fld id="{E80C50CD-E178-4744-9B35-B2F624D6C5E9}" type="datetimeFigureOut">
               <a:rPr lang="en-US" smtClean="0"/>
-              <a:t>2/8/2026</a:t>
+              <a:t>5/3/2026</a:t>
             </a:fld>
             <a:endParaRPr lang="en-US"/>
           </a:p>
@@ -9060,7 +9060,7 @@
           <a:p>
             <a:fld id="{E80C50CD-E178-4744-9B35-B2F624D6C5E9}" type="datetimeFigureOut">
               <a:rPr lang="en-US" smtClean="0"/>
-              <a:t>2/8/2026</a:t>
+              <a:t>5/3/2026</a:t>
             </a:fld>
             <a:endParaRPr lang="en-US"/>
           </a:p>
@@ -9377,7 +9377,7 @@
           <a:p>
             <a:fld id="{E80C50CD-E178-4744-9B35-B2F624D6C5E9}" type="datetimeFigureOut">
               <a:rPr lang="en-US" smtClean="0"/>
-              <a:t>2/8/2026</a:t>
+              <a:t>5/3/2026</a:t>
             </a:fld>
             <a:endParaRPr lang="en-US"/>
           </a:p>
@@ -9669,7 +9669,7 @@
           <a:p>
             <a:fld id="{E80C50CD-E178-4744-9B35-B2F624D6C5E9}" type="datetimeFigureOut">
               <a:rPr lang="en-US" smtClean="0"/>
-              <a:t>2/8/2026</a:t>
+              <a:t>5/3/2026</a:t>
             </a:fld>
             <a:endParaRPr lang="en-US"/>
           </a:p>
@@ -9909,7 +9909,7 @@
             <a:fld id="{E80C50CD-E178-4744-9B35-B2F624D6C5E9}" type="datetimeFigureOut">
               <a:rPr lang="en-US" smtClean="0"/>
               <a:pPr/>
-              <a:t>2/8/2026</a:t>
+              <a:t>5/3/2026</a:t>
             </a:fld>
             <a:endParaRPr lang="en-US"/>
           </a:p>
@@ -12141,12 +12141,14 @@
         </p:nvSpPr>
         <p:spPr>
           <a:xfrm>
-            <a:off x="518160" y="2112264"/>
-            <a:ext cx="11155680" cy="3767328"/>
+            <a:off x="518160" y="1921397"/>
+            <a:ext cx="11155680" cy="4439261"/>
           </a:xfrm>
         </p:spPr>
         <p:txBody>
-          <a:bodyPr/>
+          <a:bodyPr>
+            <a:normAutofit lnSpcReduction="10000"/>
+          </a:bodyPr>
           <a:lstStyle/>
           <a:p>
             <a:pPr marL="0" indent="0">
@@ -12320,6 +12322,33 @@
               <a:t>egymással</a:t>
             </a:r>
             <a:endParaRPr lang="en-US" sz="2400" dirty="0"/>
+          </a:p>
+          <a:p>
+            <a:pPr marL="0" indent="0">
+              <a:buNone/>
+            </a:pPr>
+            <a:endParaRPr lang="hu-HU" dirty="0"/>
+          </a:p>
+          <a:p>
+            <a:pPr marL="0" indent="0">
+              <a:buNone/>
+            </a:pPr>
+            <a:r>
+              <a:rPr lang="hu-HU" sz="2000" b="1" dirty="0"/>
+              <a:t>A </a:t>
+            </a:r>
+            <a:r>
+              <a:rPr lang="hu-HU" sz="2000" b="1" dirty="0" err="1"/>
+              <a:t>microservice</a:t>
+            </a:r>
+            <a:r>
+              <a:rPr lang="hu-HU" sz="2000" b="1" dirty="0"/>
+              <a:t> architektúra a rendszer logikai felbontása kisebb, önállóan működő, egymással kommunikáló szolgáltatásokra</a:t>
+            </a:r>
+            <a:r>
+              <a:rPr lang="hu-HU" sz="2000" dirty="0"/>
+              <a:t>.</a:t>
+            </a:r>
           </a:p>
           <a:p>
             <a:pPr marL="0" indent="0">
@@ -14163,12 +14192,32 @@
               </a:lnSpc>
             </a:pPr>
             <a:r>
+              <a:rPr lang="hu-HU" sz="2800" dirty="0"/>
+              <a:t>nagyvállalatai (</a:t>
+            </a:r>
+            <a:r>
               <a:rPr lang="en-US" sz="2800" dirty="0"/>
-              <a:t>enterprise </a:t>
+              <a:t>enterprise</a:t>
+            </a:r>
+            <a:r>
+              <a:rPr lang="hu-HU" sz="2800" dirty="0"/>
+              <a:t>)</a:t>
+            </a:r>
+            <a:r>
+              <a:rPr lang="en-US" sz="2800" dirty="0"/>
+              <a:t> </a:t>
+            </a:r>
+            <a:r>
+              <a:rPr lang="hu-HU" sz="2800" dirty="0"/>
+              <a:t>rendszerek </a:t>
             </a:r>
             <a:r>
               <a:rPr lang="en-US" sz="2800" dirty="0" err="1"/>
               <a:t>integráció</a:t>
+            </a:r>
+            <a:r>
+              <a:rPr lang="hu-HU" sz="2800" dirty="0"/>
+              <a:t>ja</a:t>
             </a:r>
             <a:endParaRPr lang="en-US" sz="2800" dirty="0"/>
           </a:p>

</xml_diff>